<commit_message>
Cut slide copy back to headline, one insight, one visual
Roughly a third of the body text removed across the deck. Supporting
paragraphs are now one or two lines, list items fit on a single line, and
each slide carries one message rather than a message plus its explanation.
No facts, figures or diagrams changed.

Card and quote blocks on slides 2, 3, 11 and 12 were re-spaced for the
shorter copy so nothing is left floating.

Co-Authored-By: Claude Opus 5 <noreply@anthropic.com>
Claude-Session: https://claude.ai/code/session_01BgnfoGWjhSacB5776oSEiC
</commit_message>
<xml_diff>
--- a/presentation/CPeak-Consultancy-Corporate-Presentation.pptx
+++ b/presentation/CPeak-Consultancy-Corporate-Presentation.pptx
@@ -2237,7 +2237,7 @@
                 <a:ea typeface="Inter" pitchFamily="34" charset="-122"/>
                 <a:cs typeface="Inter" pitchFamily="34" charset="-120"/>
               </a:rPr>
-              <a:t>An independent consultancy, built narrow on purpose: the decisions that are most expensive to reverse are the ones we do ourselves.</a:t>
+              <a:t>Built narrow on purpose: the decisions most expensive to reverse are the ones we do ourselves.</a:t>
             </a:r>
             <a:endParaRPr lang="en-US" sz="1450" dirty="0"/>
           </a:p>
@@ -2809,7 +2809,7 @@
                 <a:ea typeface="Inter" pitchFamily="34" charset="-122"/>
                 <a:cs typeface="Inter" pitchFamily="34" charset="-120"/>
               </a:rPr>
-              <a:t>Intelligent matching — bank and open items cleared from learned clearing behaviour</a:t>
+              <a:t>Intelligent matching — bank and open items cleared automatically</a:t>
             </a:r>
             <a:endParaRPr lang="en-US" sz="1100" dirty="0"/>
           </a:p>
@@ -2876,7 +2876,7 @@
                 <a:ea typeface="Inter" pitchFamily="34" charset="-122"/>
                 <a:cs typeface="Inter" pitchFamily="34" charset="-120"/>
               </a:rPr>
-              <a:t>Anomaly detection — unusual postings flagged before the close rather than after</a:t>
+              <a:t>Anomaly detection — unusual postings flagged before the close</a:t>
             </a:r>
             <a:endParaRPr lang="en-US" sz="1100" dirty="0"/>
           </a:p>
@@ -2943,7 +2943,7 @@
                 <a:ea typeface="Inter" pitchFamily="34" charset="-122"/>
                 <a:cs typeface="Inter" pitchFamily="34" charset="-120"/>
               </a:rPr>
-              <a:t>Predictive accounting — the effect of not-yet-final transactions visible during the period</a:t>
+              <a:t>Predictive accounting — the effect of not-yet-final transactions</a:t>
             </a:r>
             <a:endParaRPr lang="en-US" sz="1100" dirty="0"/>
           </a:p>
@@ -3010,7 +3010,7 @@
                 <a:ea typeface="Inter" pitchFamily="34" charset="-122"/>
                 <a:cs typeface="Inter" pitchFamily="34" charset="-120"/>
               </a:rPr>
-              <a:t>Joule — a natural-language layer for querying and navigation</a:t>
+              <a:t>Joule — natural-language querying and navigation</a:t>
             </a:r>
             <a:endParaRPr lang="en-US" sz="1100" dirty="0"/>
           </a:p>
@@ -3721,7 +3721,7 @@
                 <a:ea typeface="Inter" pitchFamily="34" charset="-122"/>
                 <a:cs typeface="Inter" pitchFamily="34" charset="-120"/>
               </a:rPr>
-              <a:t>Saying what we do not do matters as much as saying what we do. We turn the following down, because we do not believe we are the right party for it.</a:t>
+              <a:t>Saying what we do not do matters as much as saying what we do.</a:t>
             </a:r>
             <a:endParaRPr lang="en-US" sz="1250" dirty="0"/>
           </a:p>
@@ -3735,7 +3735,7 @@
         </p:nvSpPr>
         <p:spPr>
           <a:xfrm>
-            <a:off x="777240" y="4041648"/>
+            <a:off x="777240" y="3566160"/>
             <a:ext cx="0" cy="914400"/>
           </a:xfrm>
           <a:prstGeom prst="line">
@@ -3758,7 +3758,7 @@
         </p:nvSpPr>
         <p:spPr>
           <a:xfrm>
-            <a:off x="1033272" y="4041648"/>
+            <a:off x="1033272" y="3566160"/>
             <a:ext cx="4343400" cy="914400"/>
           </a:xfrm>
           <a:prstGeom prst="rect">
@@ -3890,7 +3890,7 @@
                 <a:ea typeface="Inter" pitchFamily="34" charset="-122"/>
                 <a:cs typeface="Inter" pitchFamily="34" charset="-120"/>
               </a:rPr>
-              <a:t>Lead responsibility for SAP modules outside our specialism — logistics, production planning, HR</a:t>
+              <a:t>Lead responsibility for modules outside our specialism — logistics, production planning, HR</a:t>
             </a:r>
             <a:endParaRPr lang="en-US" sz="1200" dirty="0"/>
           </a:p>
@@ -3994,7 +3994,7 @@
                 <a:ea typeface="Inter" pitchFamily="34" charset="-122"/>
                 <a:cs typeface="Inter" pitchFamily="34" charset="-120"/>
               </a:rPr>
-              <a:t>Staff augmentation: supplying capacity without architectural or delivery responsibility</a:t>
+              <a:t>Staff augmentation without architectural or delivery responsibility</a:t>
             </a:r>
             <a:endParaRPr lang="en-US" sz="1200" dirty="0"/>
           </a:p>
@@ -4098,7 +4098,7 @@
                 <a:ea typeface="Inter" pitchFamily="34" charset="-122"/>
                 <a:cs typeface="Inter" pitchFamily="34" charset="-120"/>
               </a:rPr>
-              <a:t>Fixed-price transformation commitments made before an assessment has been done</a:t>
+              <a:t>Fixed-price commitments made before an assessment</a:t>
             </a:r>
             <a:endParaRPr lang="en-US" sz="1200" dirty="0"/>
           </a:p>
@@ -4473,8 +4473,8 @@
         </p:nvSpPr>
         <p:spPr>
           <a:xfrm>
-            <a:off x="777240" y="2359152"/>
-            <a:ext cx="3310128" cy="3364992"/>
+            <a:off x="777240" y="2395728"/>
+            <a:ext cx="3310128" cy="3035808"/>
           </a:xfrm>
           <a:prstGeom prst="rect">
             <a:avLst/>
@@ -4505,7 +4505,7 @@
         </p:nvSpPr>
         <p:spPr>
           <a:xfrm>
-            <a:off x="1129284" y="2766060"/>
+            <a:off x="1129284" y="2802636"/>
             <a:ext cx="137160" cy="137160"/>
           </a:xfrm>
           <a:prstGeom prst="ellipse">
@@ -4530,7 +4530,7 @@
         </p:nvSpPr>
         <p:spPr>
           <a:xfrm>
-            <a:off x="1197864" y="3035808"/>
+            <a:off x="1197864" y="3072384"/>
             <a:ext cx="2468880" cy="384048"/>
           </a:xfrm>
           <a:prstGeom prst="rect">
@@ -4569,8 +4569,8 @@
         </p:nvSpPr>
         <p:spPr>
           <a:xfrm>
-            <a:off x="1197864" y="3493008"/>
-            <a:ext cx="2468880" cy="1280160"/>
+            <a:off x="1197864" y="3529584"/>
+            <a:ext cx="2468880" cy="1005840"/>
           </a:xfrm>
           <a:prstGeom prst="rect">
             <a:avLst/>
@@ -4597,7 +4597,7 @@
                 <a:ea typeface="Inter" pitchFamily="34" charset="-122"/>
                 <a:cs typeface="Inter" pitchFamily="34" charset="-120"/>
               </a:rPr>
-              <a:t>A decision has to be taken and the evidence for it is missing: conversion route, cloud model, or a health check on the landscape you run today.</a:t>
+              <a:t>A decision has to be taken and the evidence is missing: conversion route, cloud model, a health check.</a:t>
             </a:r>
             <a:endParaRPr lang="en-US" sz="1100" dirty="0"/>
           </a:p>
@@ -4611,7 +4611,7 @@
         </p:nvSpPr>
         <p:spPr>
           <a:xfrm>
-            <a:off x="1197864" y="4846320"/>
+            <a:off x="1197864" y="4608576"/>
             <a:ext cx="2468880" cy="0"/>
           </a:xfrm>
           <a:prstGeom prst="line">
@@ -4634,7 +4634,7 @@
         </p:nvSpPr>
         <p:spPr>
           <a:xfrm>
-            <a:off x="1197864" y="4974336"/>
+            <a:off x="1197864" y="4736592"/>
             <a:ext cx="2468880" cy="475488"/>
           </a:xfrm>
           <a:prstGeom prst="rect">
@@ -4676,7 +4676,7 @@
         </p:nvSpPr>
         <p:spPr>
           <a:xfrm>
-            <a:off x="1197864" y="5431536"/>
+            <a:off x="1197864" y="5157216"/>
             <a:ext cx="2468880" cy="256032"/>
           </a:xfrm>
           <a:prstGeom prst="rect">
@@ -4715,8 +4715,8 @@
         </p:nvSpPr>
         <p:spPr>
           <a:xfrm>
-            <a:off x="4471416" y="2359152"/>
-            <a:ext cx="3310128" cy="3364992"/>
+            <a:off x="4471416" y="2395728"/>
+            <a:ext cx="3310128" cy="3035808"/>
           </a:xfrm>
           <a:prstGeom prst="rect">
             <a:avLst/>
@@ -4747,7 +4747,7 @@
         </p:nvSpPr>
         <p:spPr>
           <a:xfrm>
-            <a:off x="4823460" y="2766060"/>
+            <a:off x="4823460" y="2802636"/>
             <a:ext cx="137160" cy="137160"/>
           </a:xfrm>
           <a:prstGeom prst="ellipse">
@@ -4772,7 +4772,7 @@
         </p:nvSpPr>
         <p:spPr>
           <a:xfrm>
-            <a:off x="4892040" y="3035808"/>
+            <a:off x="4892040" y="3072384"/>
             <a:ext cx="2468880" cy="384048"/>
           </a:xfrm>
           <a:prstGeom prst="rect">
@@ -4811,8 +4811,8 @@
         </p:nvSpPr>
         <p:spPr>
           <a:xfrm>
-            <a:off x="4892040" y="3493008"/>
-            <a:ext cx="2468880" cy="1280160"/>
+            <a:off x="4892040" y="3529584"/>
+            <a:ext cx="2468880" cy="1005840"/>
           </a:xfrm>
           <a:prstGeom prst="rect">
             <a:avLst/>
@@ -4839,7 +4839,7 @@
                 <a:ea typeface="Inter" pitchFamily="34" charset="-122"/>
                 <a:cs typeface="Inter" pitchFamily="34" charset="-120"/>
               </a:rPr>
-              <a:t>The decision is taken and it needs building: a transformation, an implementation or a substantial redesign.</a:t>
+              <a:t>The decision is taken and it needs building: a transformation, an implementation, a redesign.</a:t>
             </a:r>
             <a:endParaRPr lang="en-US" sz="1100" dirty="0"/>
           </a:p>
@@ -4853,7 +4853,7 @@
         </p:nvSpPr>
         <p:spPr>
           <a:xfrm>
-            <a:off x="4892040" y="4846320"/>
+            <a:off x="4892040" y="4608576"/>
             <a:ext cx="2468880" cy="0"/>
           </a:xfrm>
           <a:prstGeom prst="line">
@@ -4876,7 +4876,7 @@
         </p:nvSpPr>
         <p:spPr>
           <a:xfrm>
-            <a:off x="4892040" y="4974336"/>
+            <a:off x="4892040" y="4736592"/>
             <a:ext cx="2468880" cy="475488"/>
           </a:xfrm>
           <a:prstGeom prst="rect">
@@ -4918,7 +4918,7 @@
         </p:nvSpPr>
         <p:spPr>
           <a:xfrm>
-            <a:off x="4892040" y="5431536"/>
+            <a:off x="4892040" y="5157216"/>
             <a:ext cx="2468880" cy="256032"/>
           </a:xfrm>
           <a:prstGeom prst="rect">
@@ -4957,8 +4957,8 @@
         </p:nvSpPr>
         <p:spPr>
           <a:xfrm>
-            <a:off x="8165592" y="2359152"/>
-            <a:ext cx="3310128" cy="3364992"/>
+            <a:off x="8165592" y="2395728"/>
+            <a:ext cx="3310128" cy="3035808"/>
           </a:xfrm>
           <a:prstGeom prst="rect">
             <a:avLst/>
@@ -4989,7 +4989,7 @@
         </p:nvSpPr>
         <p:spPr>
           <a:xfrm>
-            <a:off x="8517636" y="2766060"/>
+            <a:off x="8517636" y="2802636"/>
             <a:ext cx="137160" cy="137160"/>
           </a:xfrm>
           <a:prstGeom prst="ellipse">
@@ -5014,7 +5014,7 @@
         </p:nvSpPr>
         <p:spPr>
           <a:xfrm>
-            <a:off x="8586216" y="3035808"/>
+            <a:off x="8586216" y="3072384"/>
             <a:ext cx="2468880" cy="384048"/>
           </a:xfrm>
           <a:prstGeom prst="rect">
@@ -5053,8 +5053,8 @@
         </p:nvSpPr>
         <p:spPr>
           <a:xfrm>
-            <a:off x="8586216" y="3493008"/>
-            <a:ext cx="2468880" cy="1280160"/>
+            <a:off x="8586216" y="3529584"/>
+            <a:ext cx="2468880" cy="1005840"/>
           </a:xfrm>
           <a:prstGeom prst="rect">
             <a:avLst/>
@@ -5081,7 +5081,7 @@
                 <a:ea typeface="Inter" pitchFamily="34" charset="-122"/>
                 <a:cs typeface="Inter" pitchFamily="34" charset="-120"/>
               </a:rPr>
-              <a:t>Your team or another partner runs the programme and depth is needed in one place: a design review, a second opinion, one workstream.</a:t>
+              <a:t>Someone else runs the programme and depth is needed in one place: a review, a second opinion, one workstream.</a:t>
             </a:r>
             <a:endParaRPr lang="en-US" sz="1100" dirty="0"/>
           </a:p>
@@ -5095,7 +5095,7 @@
         </p:nvSpPr>
         <p:spPr>
           <a:xfrm>
-            <a:off x="8586216" y="4846320"/>
+            <a:off x="8586216" y="4608576"/>
             <a:ext cx="2468880" cy="0"/>
           </a:xfrm>
           <a:prstGeom prst="line">
@@ -5118,7 +5118,7 @@
         </p:nvSpPr>
         <p:spPr>
           <a:xfrm>
-            <a:off x="8586216" y="4974336"/>
+            <a:off x="8586216" y="4736592"/>
             <a:ext cx="2468880" cy="475488"/>
           </a:xfrm>
           <a:prstGeom prst="rect">
@@ -5160,7 +5160,7 @@
         </p:nvSpPr>
         <p:spPr>
           <a:xfrm>
-            <a:off x="8586216" y="5431536"/>
+            <a:off x="8586216" y="5157216"/>
             <a:ext cx="2468880" cy="256032"/>
           </a:xfrm>
           <a:prstGeom prst="rect">
@@ -5500,7 +5500,7 @@
                 <a:ea typeface="Inter" pitchFamily="34" charset="-122"/>
                 <a:cs typeface="Inter" pitchFamily="34" charset="-120"/>
               </a:rPr>
-              <a:t>More than ten years of hands-on delivery across SAP finance modules and cloud architecture — in multi-entity groups, regulated industries and high-volume operations.</a:t>
+              <a:t>More than ten years across SAP finance modules and cloud architecture.</a:t>
             </a:r>
             <a:endParaRPr lang="en-US" sz="1200" dirty="0"/>
           </a:p>
@@ -6265,7 +6265,7 @@
                 <a:ea typeface="Inter" pitchFamily="34" charset="-122"/>
                 <a:cs typeface="Inter" pitchFamily="34" charset="-120"/>
               </a:rPr>
-              <a:t>The team is small and senior. You are not charged for a consultant’s learning curve.</a:t>
+              <a:t>A small, senior team. No one’s learning curve on your budget.</a:t>
             </a:r>
             <a:endParaRPr lang="en-US" sz="1100" dirty="0"/>
           </a:p>
@@ -6396,7 +6396,7 @@
                 <a:ea typeface="Inter" pitchFamily="34" charset="-122"/>
                 <a:cs typeface="Inter" pitchFamily="34" charset="-120"/>
               </a:rPr>
-              <a:t>We stay in finance and cloud architecture. The difficult part is not subcontracted.</a:t>
+              <a:t>Finance and cloud architecture only. The difficult part is not subcontracted.</a:t>
             </a:r>
             <a:endParaRPr lang="en-US" sz="1100" dirty="0"/>
           </a:p>
@@ -6527,7 +6527,7 @@
                 <a:ea typeface="Inter" pitchFamily="34" charset="-122"/>
                 <a:cs typeface="Inter" pitchFamily="34" charset="-120"/>
               </a:rPr>
-              <a:t>We compare, you decide, and the reasoning stays on paper for the people who ask later.</a:t>
+              <a:t>We compare, you decide, the reasoning stays on paper.</a:t>
             </a:r>
             <a:endParaRPr lang="en-US" sz="1100" dirty="0"/>
           </a:p>
@@ -6658,7 +6658,7 @@
                 <a:ea typeface="Inter" pitchFamily="34" charset="-122"/>
                 <a:cs typeface="Inter" pitchFamily="34" charset="-120"/>
               </a:rPr>
-              <a:t>When scope grows we phase the work rather than inflate the team.</a:t>
+              <a:t>Scope grows in phases, not in headcount.</a:t>
             </a:r>
             <a:endParaRPr lang="en-US" sz="1100" dirty="0"/>
           </a:p>
@@ -7263,7 +7263,7 @@
                 <a:ea typeface="Inter" pitchFamily="34" charset="-122"/>
                 <a:cs typeface="Inter" pitchFamily="34" charset="-120"/>
               </a:rPr>
-              <a:t>The common model in SAP consulting is to sell broad scope, then source a different specialist for each area. It reads well in a proposal — and it is how the most consequential finance decision ends up with the person who has seen it least often.</a:t>
+              <a:t>Sell broad scope, then source a specialist for each area — and the most consequential finance decision reaches the person who has seen it least often.</a:t>
             </a:r>
             <a:endParaRPr lang="en-US" sz="1350" dirty="0"/>
           </a:p>
@@ -7277,7 +7277,7 @@
         </p:nvSpPr>
         <p:spPr>
           <a:xfrm>
-            <a:off x="777240" y="4434840"/>
+            <a:off x="777240" y="3931920"/>
             <a:ext cx="0" cy="914400"/>
           </a:xfrm>
           <a:prstGeom prst="line">
@@ -7300,7 +7300,7 @@
         </p:nvSpPr>
         <p:spPr>
           <a:xfrm>
-            <a:off x="1033272" y="4434840"/>
+            <a:off x="1033272" y="3931920"/>
             <a:ext cx="4617720" cy="914400"/>
           </a:xfrm>
           <a:prstGeom prst="rect">
@@ -8462,7 +8462,7 @@
                 <a:ea typeface="Inter" pitchFamily="34" charset="-122"/>
                 <a:cs typeface="Inter" pitchFamily="34" charset="-120"/>
               </a:rPr>
-              <a:t>Enterprise structure. Conversion route. Cloud model. Each is settled in the opening weeks of a programme and paid for over the decade that follows.</a:t>
+              <a:t>Enterprise structure. Conversion route. Cloud model. Settled in the opening weeks — paid for over the next decade.</a:t>
             </a:r>
             <a:endParaRPr lang="en-US" sz="1300" dirty="0"/>
           </a:p>
@@ -8476,7 +8476,7 @@
         </p:nvSpPr>
         <p:spPr>
           <a:xfrm>
-            <a:off x="777240" y="4224528"/>
+            <a:off x="777240" y="3950208"/>
             <a:ext cx="0" cy="914400"/>
           </a:xfrm>
           <a:prstGeom prst="line">
@@ -8499,7 +8499,7 @@
         </p:nvSpPr>
         <p:spPr>
           <a:xfrm>
-            <a:off x="1033272" y="4224528"/>
+            <a:off x="1033272" y="3950208"/>
             <a:ext cx="4572000" cy="914400"/>
           </a:xfrm>
           <a:prstGeom prst="rect">
@@ -9361,7 +9361,7 @@
                 <a:ea typeface="Inter" pitchFamily="34" charset="-122"/>
                 <a:cs typeface="Inter" pitchFamily="34" charset="-120"/>
               </a:rPr>
-              <a:t>FI, CO, PA and PS — enterprise structure, chart of accounts, costing, margin and the close calendar.</a:t>
+              <a:t>FI, CO, PA and PS — structure, costing, margin, the close.</a:t>
             </a:r>
             <a:endParaRPr lang="en-US" sz="1100" dirty="0"/>
           </a:p>
@@ -9532,7 +9532,7 @@
                 <a:ea typeface="Inter" pitchFamily="34" charset="-122"/>
                 <a:cs typeface="Inter" pitchFamily="34" charset="-120"/>
               </a:rPr>
-              <a:t>ECC, S/4HANA on-premise, Cloud ERP Private Edition and Public Edition — compared, not advocated.</a:t>
+              <a:t>ECC, S/4HANA, Private and Public Cloud — compared, not advocated.</a:t>
             </a:r>
             <a:endParaRPr lang="en-US" sz="1100" dirty="0"/>
           </a:p>
@@ -9703,7 +9703,7 @@
                 <a:ea typeface="Inter" pitchFamily="34" charset="-122"/>
                 <a:cs typeface="Inter" pitchFamily="34" charset="-120"/>
               </a:rPr>
-              <a:t>SAP’s embedded AI in matching, anomaly detection and predictive accounting — measured before enabling.</a:t>
+              <a:t>Matching, anomaly detection, predictive accounting — measured before enabling.</a:t>
             </a:r>
             <a:endParaRPr lang="en-US" sz="1100" dirty="0"/>
           </a:p>
@@ -10890,7 +10890,7 @@
                 <a:ea typeface="Inter" pitchFamily="34" charset="-122"/>
                 <a:cs typeface="Inter" pitchFamily="34" charset="-120"/>
               </a:rPr>
-              <a:t>Every recommendation starts from what the system is doing, not from what the process documentation says it does. The distance between the two is not a detail — in most landscapes it is the problem itself.</a:t>
+              <a:t>What the system does, not what the documentation says it does. The distance between the two is usually the problem itself.</a:t>
             </a:r>
             <a:endParaRPr lang="en-US" sz="1150" dirty="0"/>
           </a:p>
@@ -11422,7 +11422,7 @@
                 <a:ea typeface="Inter" pitchFamily="34" charset="-122"/>
                 <a:cs typeface="Inter" pitchFamily="34" charset="-120"/>
               </a:rPr>
-              <a:t>Speed, a predictable run cost and upgrades you do not manage — in exchange for a core that cannot be modified.</a:t>
+              <a:t>Speed and a predictable run cost — for a core that cannot be modified.</a:t>
             </a:r>
             <a:endParaRPr lang="en-US" sz="1150" dirty="0"/>
           </a:p>
@@ -11645,7 +11645,7 @@
                 <a:ea typeface="Inter" pitchFamily="34" charset="-122"/>
                 <a:cs typeface="Inter" pitchFamily="34" charset="-120"/>
               </a:rPr>
-              <a:t>Flexibility, including your own developments — in exchange for more responsibility and a longer implementation.</a:t>
+              <a:t>Your own developments kept — for more responsibility and a longer build.</a:t>
             </a:r>
             <a:endParaRPr lang="en-US" sz="1150" dirty="0"/>
           </a:p>
@@ -11854,7 +11854,7 @@
                 <a:ea typeface="Inter" pitchFamily="34" charset="-122"/>
                 <a:cs typeface="Inter" pitchFamily="34" charset="-120"/>
               </a:rPr>
-              <a:t>Neither is the advanced version of the other. We compare your processes against standard scope item by item, put both costs and both constraints side by side, and leave the reasoning on paper. The decision stays yours — and the right moment to take it is before signing.</a:t>
+              <a:t>Neither is the advanced version of the other. We put both costs and both constraints side by side; the decision stays yours, and the moment to take it is before signing.</a:t>
             </a:r>
             <a:endParaRPr lang="en-US" sz="1150" dirty="0"/>
           </a:p>
@@ -12130,7 +12130,7 @@
                 <a:ea typeface="Inter" pitchFamily="34" charset="-122"/>
                 <a:cs typeface="Inter" pitchFamily="34" charset="-120"/>
               </a:rPr>
-              <a:t>What each stage delivers is agreed before it begins, and the decision to continue is taken again at every gate. That is what stops a programme collapsing under its own weight.</a:t>
+              <a:t>What each stage delivers is agreed before it begins. At every gate the decision to continue is taken again.</a:t>
             </a:r>
             <a:endParaRPr lang="en-US" sz="1150" dirty="0"/>
           </a:p>
@@ -12301,7 +12301,7 @@
                 <a:ea typeface="Inter" pitchFamily="34" charset="-122"/>
                 <a:cs typeface="Inter" pitchFamily="34" charset="-120"/>
               </a:rPr>
-              <a:t>Diagnostic report with prioritised findings, read from system data</a:t>
+              <a:t>Diagnostic report, read from system data</a:t>
             </a:r>
             <a:endParaRPr lang="en-US" sz="1050" dirty="0"/>
           </a:p>
@@ -12593,7 +12593,7 @@
                 <a:ea typeface="Inter" pitchFamily="34" charset="-122"/>
                 <a:cs typeface="Inter" pitchFamily="34" charset="-120"/>
               </a:rPr>
-              <a:t>Target architecture and a phased roadmap, options costed side by side</a:t>
+              <a:t>Target architecture and phased roadmap</a:t>
             </a:r>
             <a:endParaRPr lang="en-US" sz="1050" dirty="0"/>
           </a:p>
@@ -12865,7 +12865,7 @@
                 <a:ea typeface="Inter" pitchFamily="34" charset="-122"/>
                 <a:cs typeface="Inter" pitchFamily="34" charset="-120"/>
               </a:rPr>
-              <a:t>Working system, test records and an hour-by-hour cutover plan</a:t>
+              <a:t>Working system, test records, cutover plan</a:t>
             </a:r>
             <a:endParaRPr lang="en-US" sz="1050" dirty="0"/>
           </a:p>
@@ -13137,7 +13137,7 @@
                 <a:ea typeface="Inter" pitchFamily="34" charset="-122"/>
                 <a:cs typeface="Inter" pitchFamily="34" charset="-120"/>
               </a:rPr>
-              <a:t>The first close run alongside your team, plus an improvement backlog</a:t>
+              <a:t>First close run with your team, improvement backlog</a:t>
             </a:r>
             <a:endParaRPr lang="en-US" sz="1050" dirty="0"/>
           </a:p>
@@ -13657,7 +13657,7 @@
                 <a:ea typeface="Inter" pitchFamily="34" charset="-122"/>
                 <a:cs typeface="Inter" pitchFamily="34" charset="-120"/>
               </a:rPr>
-              <a:t>Rebuild the close so steps run in parallel instead of waiting on each other</a:t>
+              <a:t>Rebuild the close to run in parallel, not in sequence</a:t>
             </a:r>
             <a:endParaRPr lang="en-US" sz="1150" dirty="0"/>
           </a:p>
@@ -13814,7 +13814,7 @@
                 <a:ea typeface="Inter" pitchFamily="34" charset="-122"/>
                 <a:cs typeface="Inter" pitchFamily="34" charset="-120"/>
               </a:rPr>
-              <a:t>A genuinely neutral read on the cloud models</a:t>
+              <a:t>A neutral read on the cloud models</a:t>
             </a:r>
             <a:endParaRPr lang="en-US" sz="1150" dirty="0"/>
           </a:p>
@@ -13856,7 +13856,7 @@
                 <a:ea typeface="Inter" pitchFamily="34" charset="-122"/>
                 <a:cs typeface="Inter" pitchFamily="34" charset="-120"/>
               </a:rPr>
-              <a:t>Compare your processes against standard scope, item by item, before the contract</a:t>
+              <a:t>Compare your processes to standard scope, before the contract</a:t>
             </a:r>
             <a:endParaRPr lang="en-US" sz="1150" dirty="0"/>
           </a:p>
@@ -14055,7 +14055,7 @@
                 <a:ea typeface="Inter" pitchFamily="34" charset="-122"/>
                 <a:cs typeface="Inter" pitchFamily="34" charset="-120"/>
               </a:rPr>
-              <a:t>Calibrate matching thresholds against your own data and write the oversight rules down</a:t>
+              <a:t>Calibrate thresholds on your own data, write the oversight rules down</a:t>
             </a:r>
             <a:endParaRPr lang="en-US" sz="1150" dirty="0"/>
           </a:p>

</xml_diff>